<commit_message>
Remove Utah Highway Patrol and personal email from docs
</commit_message>
<xml_diff>
--- a/docs/MMMF_Teach_the_Teacher.pptx
+++ b/docs/MMMF_Teach_the_Teacher.pptx
@@ -2437,7 +2437,7 @@
                   <a:srgbClr val="6B7280"/>
                 </a:solidFill>
               </a:rPr>
-              <a:t>Utah Highway Patrol Sergeant  ·  MAT Candidate  ·  Kappa Delta Pi</a:t>
+              <a:t>Founder  ·  Curriculum Designer  ·  Kappa Delta Pi</a:t>
             </a:r>
             <a:endParaRPr lang="en-US" sz="1000" dirty="0"/>
           </a:p>
@@ -9565,7 +9565,7 @@
                   <a:srgbClr val="6B7280"/>
                 </a:solidFill>
               </a:rPr>
-              <a:t>readyforreal.life  ·  Michael R. Terry  ·  mikeyterry44@gmail.com</a:t>
+              <a:t>readyforreal.life  ·  Michael R. Terry  ·  readyforreal.life44@gmail.com</a:t>
             </a:r>
             <a:endParaRPr lang="en-US" sz="1100" dirty="0"/>
           </a:p>
@@ -10506,7 +10506,7 @@
                   <a:srgbClr val="FFFFFF"/>
                 </a:solidFill>
               </a:rPr>
-              <a:t>🚔  Utah Highway Patrol Sergeant</a:t>
+              <a:t>🚔  Founder and Curriculum Designer</a:t>
             </a:r>
             <a:endParaRPr lang="en-US" sz="1100" dirty="0"/>
           </a:p>
@@ -10542,7 +10542,7 @@
                   <a:srgbClr val="FFFFFF"/>
                 </a:solidFill>
               </a:rPr>
-              <a:t>🎓  MAT Candidate — Columbia College of Missouri</a:t>
+              <a:t>🎓  Master of Arts in Teaching — Columbia College of Missouri</a:t>
             </a:r>
             <a:endParaRPr lang="en-US" sz="1100" dirty="0"/>
           </a:p>

</xml_diff>

<commit_message>
Apply Ready for Real Life branding to formal materials
</commit_message>
<xml_diff>
--- a/docs/MMMF_Teach_the_Teacher.pptx
+++ b/docs/MMMF_Teach_the_Teacher.pptx
@@ -2226,7 +2226,7 @@
                   <a:srgbClr val="C89B3C"/>
                 </a:solidFill>
               </a:rPr>
-              <a:t>MODERN MANNERS &amp; MENTAL FORTITUDE</a:t>
+              <a:t>READY FOR REAL LIFE INSTRUCTION AND EDUCATION</a:t>
             </a:r>
             <a:endParaRPr lang="en-US" sz="1000" dirty="0"/>
           </a:p>
@@ -9398,7 +9398,7 @@
                   <a:srgbClr val="C89B3C"/>
                 </a:solidFill>
               </a:rPr>
-              <a:t>MODERN MANNERS &amp; MENTAL FORTITUDE</a:t>
+              <a:t>READY FOR REAL LIFE INSTRUCTION AND EDUCATION</a:t>
             </a:r>
             <a:endParaRPr lang="en-US" sz="1000" dirty="0"/>
           </a:p>
@@ -9565,7 +9565,7 @@
                   <a:srgbClr val="6B7280"/>
                 </a:solidFill>
               </a:rPr>
-              <a:t>readyforreal.life  ·  Michael R. Terry  ·  readyforreal.life44@gmail.com</a:t>
+              <a:t>readyforreal.life  ·  Founders, Ready for Real Life Instruction and Education | MMMF LLC  ·  readyforreal.life44@gmail.com</a:t>
             </a:r>
             <a:endParaRPr lang="en-US" sz="1100" dirty="0"/>
           </a:p>

</xml_diff>

<commit_message>
Polish formal documents copy and deck layout
</commit_message>
<xml_diff>
--- a/docs/MMMF_Teach_the_Teacher.pptx
+++ b/docs/MMMF_Teach_the_Teacher.pptx
@@ -9672,8 +9672,8 @@
         </p:nvSpPr>
         <p:spPr>
           <a:xfrm>
-            <a:off x="365760" y="91440"/>
-            <a:ext cx="8229600" cy="640080"/>
+            <a:off x="365760" y="73152"/>
+            <a:ext cx="8229600" cy="457200"/>
           </a:xfrm>
           <a:prstGeom prst="rect">
             <a:avLst/>
@@ -9708,8 +9708,8 @@
         </p:nvSpPr>
         <p:spPr>
           <a:xfrm>
-            <a:off x="365760" y="201168"/>
-            <a:ext cx="8229600" cy="502920"/>
+            <a:off x="365760" y="256032"/>
+            <a:ext cx="8229600" cy="557784"/>
           </a:xfrm>
           <a:prstGeom prst="rect">
             <a:avLst/>
@@ -9725,7 +9725,7 @@
               <a:buNone/>
             </a:pPr>
             <a:r>
-              <a:rPr lang="en-US" sz="2200" b="1" dirty="0">
+              <a:rPr lang="en-US" sz="2000" b="1" dirty="0">
                 <a:solidFill>
                   <a:srgbClr val="FFFFFF"/>
                 </a:solidFill>

</xml_diff>